<commit_message>
Finalize validation and presentation updates
</commit_message>
<xml_diff>
--- a/slides/DepoIndex_Presentation.pptx
+++ b/slides/DepoIndex_Presentation.pptx
@@ -3875,7 +3875,7 @@
               </a:defRPr>
             </a:pPr>
             <a:r>
-              <a:t>• Cross-Span Linking: Returning topics record recurrence_of and related_topic_ids, allowing attorneys to jump between related spans.</a:t>
+              <a:t>• Recurrence Handling: Recurrence architecture implemented (recurrence_of, related_topic_ids); no recurrence link was triggered on this deposition.</a:t>
             </a:r>
           </a:p>
         </p:txBody>
@@ -4274,7 +4274,7 @@
               </a:defRPr>
             </a:pPr>
             <a:r>
-              <a:t>• Boundary Quality: 96.0% (clean alignment with question transitions and exhibit shifts).</a:t>
+              <a:t>• Boundary Quality: 95.5% (clean alignment with question transitions and exhibit shifts).</a:t>
             </a:r>
           </a:p>
           <a:p>

</xml_diff>